<commit_message>
Welcome presentation + minor update in MCP presentation
</commit_message>
<xml_diff>
--- a/Presentations/MCP_Servers_for_Biomedical_Research.pptx
+++ b/Presentations/MCP_Servers_for_Biomedical_Research.pptx
@@ -4797,8 +4797,38 @@
         </p:blipFill>
         <p:spPr>
           <a:xfrm>
-            <a:off x="398874" y="3108960"/>
-            <a:ext cx="6700332" cy="3063240"/>
+            <a:off x="7207135" y="3891742"/>
+            <a:ext cx="4838118" cy="2211878"/>
+          </a:xfrm>
+          <a:prstGeom prst="rect">
+            <a:avLst/>
+          </a:prstGeom>
+        </p:spPr>
+      </p:pic>
+      <p:pic>
+        <p:nvPicPr>
+          <p:cNvPr id="5" name="Obrázek 4">
+            <a:extLst>
+              <a:ext uri="{FF2B5EF4-FFF2-40B4-BE49-F238E27FC236}">
+                <a16:creationId xmlns:a16="http://schemas.microsoft.com/office/drawing/2014/main" id="{667F6171-641F-03C9-EAB1-8A25DCC59E30}"/>
+              </a:ext>
+            </a:extLst>
+          </p:cNvPr>
+          <p:cNvPicPr>
+            <a:picLocks noChangeAspect="1"/>
+          </p:cNvPicPr>
+          <p:nvPr/>
+        </p:nvPicPr>
+        <p:blipFill>
+          <a:blip r:embed="rId3"/>
+          <a:stretch>
+            <a:fillRect/>
+          </a:stretch>
+        </p:blipFill>
+        <p:spPr>
+          <a:xfrm>
+            <a:off x="97746" y="3042340"/>
+            <a:ext cx="6943134" cy="2876441"/>
           </a:xfrm>
           <a:prstGeom prst="rect">
             <a:avLst/>
@@ -5106,7 +5136,7 @@
         </p:blipFill>
         <p:spPr>
           <a:xfrm>
-            <a:off x="243325" y="1756185"/>
+            <a:off x="121662" y="1632866"/>
             <a:ext cx="11948675" cy="3345629"/>
           </a:xfrm>
           <a:prstGeom prst="rect">

</xml_diff>